<commit_message>
update colab link after renaming notebooks
</commit_message>
<xml_diff>
--- a/20243/Part 2-Regression/simple linear regression slides.pptx
+++ b/20243/Part 2-Regression/simple linear regression slides.pptx
@@ -135,8 +135,7 @@
 <file path=ppt/revisionInfo.xml><?xml version="1.0" encoding="utf-8"?>
 <p1510:revInfo xmlns:a="http://schemas.openxmlformats.org/drawingml/2006/main" xmlns:r="http://schemas.openxmlformats.org/officeDocument/2006/relationships" xmlns:p1510="http://schemas.microsoft.com/office/powerpoint/2015/10/main">
   <p1510:revLst>
-    <p1510:client id="{161A7FAA-B398-4429-9FC2-656B0895AF0F}" v="51" dt="2025-07-16T08:30:59.062"/>
-    <p1510:client id="{F585A28F-34F7-4D28-B641-78252DAB29E0}" v="1" dt="2025-07-16T09:16:07.771"/>
+    <p1510:client id="{0455E0E6-2388-40FF-8789-A613D1CB1008}" v="8" dt="2025-07-26T17:40:12.131"/>
   </p1510:revLst>
 </p1510:revInfo>
 </file>
@@ -1009,22 +1008,6 @@
           <pc:docMk/>
           <pc:sldMk cId="1040197143" sldId="460"/>
         </pc:sldMkLst>
-        <pc:picChg chg="del">
-          <ac:chgData name="Mohammed Fasha" userId="cc64f42d-a1a6-4f08-b97b-0c37f877119f" providerId="ADAL" clId="{161A7FAA-B398-4429-9FC2-656B0895AF0F}" dt="2025-07-16T08:18:58.259" v="234" actId="21"/>
-          <ac:picMkLst>
-            <pc:docMk/>
-            <pc:sldMk cId="1040197143" sldId="460"/>
-            <ac:picMk id="12" creationId="{ED72E220-66E3-C895-AA2B-7821BAB0B80F}"/>
-          </ac:picMkLst>
-        </pc:picChg>
-        <pc:picChg chg="del">
-          <ac:chgData name="Mohammed Fasha" userId="cc64f42d-a1a6-4f08-b97b-0c37f877119f" providerId="ADAL" clId="{161A7FAA-B398-4429-9FC2-656B0895AF0F}" dt="2025-07-16T08:19:12.149" v="237" actId="21"/>
-          <ac:picMkLst>
-            <pc:docMk/>
-            <pc:sldMk cId="1040197143" sldId="460"/>
-            <ac:picMk id="13" creationId="{923AB4FC-8803-B130-E7FF-D6F9B65D8759}"/>
-          </ac:picMkLst>
-        </pc:picChg>
       </pc:sldChg>
       <pc:sldChg chg="modSp mod ord">
         <pc:chgData name="Mohammed Fasha" userId="cc64f42d-a1a6-4f08-b97b-0c37f877119f" providerId="ADAL" clId="{161A7FAA-B398-4429-9FC2-656B0895AF0F}" dt="2025-07-16T08:31:04.392" v="376" actId="5793"/>
@@ -1063,30 +1046,6 @@
             <ac:spMk id="3" creationId="{A955792E-C166-AD40-E023-9C9473F341EE}"/>
           </ac:spMkLst>
         </pc:spChg>
-        <pc:picChg chg="add del">
-          <ac:chgData name="Mohammed Fasha" userId="cc64f42d-a1a6-4f08-b97b-0c37f877119f" providerId="ADAL" clId="{161A7FAA-B398-4429-9FC2-656B0895AF0F}" dt="2025-07-16T08:05:48.658" v="91" actId="478"/>
-          <ac:picMkLst>
-            <pc:docMk/>
-            <pc:sldMk cId="2300765676" sldId="477"/>
-            <ac:picMk id="5" creationId="{45D6DA4C-2F0D-260B-8062-714BA9263593}"/>
-          </ac:picMkLst>
-        </pc:picChg>
-        <pc:picChg chg="add del mod">
-          <ac:chgData name="Mohammed Fasha" userId="cc64f42d-a1a6-4f08-b97b-0c37f877119f" providerId="ADAL" clId="{161A7FAA-B398-4429-9FC2-656B0895AF0F}" dt="2025-07-16T08:04:14.371" v="84" actId="478"/>
-          <ac:picMkLst>
-            <pc:docMk/>
-            <pc:sldMk cId="2300765676" sldId="477"/>
-            <ac:picMk id="1026" creationId="{F9570969-F598-6ACB-2DD4-CCA2812970C4}"/>
-          </ac:picMkLst>
-        </pc:picChg>
-        <pc:picChg chg="add del mod">
-          <ac:chgData name="Mohammed Fasha" userId="cc64f42d-a1a6-4f08-b97b-0c37f877119f" providerId="ADAL" clId="{161A7FAA-B398-4429-9FC2-656B0895AF0F}" dt="2025-07-16T08:05:11.635" v="89" actId="478"/>
-          <ac:picMkLst>
-            <pc:docMk/>
-            <pc:sldMk cId="2300765676" sldId="477"/>
-            <ac:picMk id="1028" creationId="{6CD59B2C-D8DA-FE8A-6FE6-FA28D990AF89}"/>
-          </ac:picMkLst>
-        </pc:picChg>
         <pc:picChg chg="add mod">
           <ac:chgData name="Mohammed Fasha" userId="cc64f42d-a1a6-4f08-b97b-0c37f877119f" providerId="ADAL" clId="{161A7FAA-B398-4429-9FC2-656B0895AF0F}" dt="2025-07-16T08:08:48.133" v="117" actId="1076"/>
           <ac:picMkLst>
@@ -1125,22 +1084,6 @@
           <pc:docMk/>
           <pc:sldMk cId="575657110" sldId="479"/>
         </pc:sldMkLst>
-        <pc:spChg chg="add del mod">
-          <ac:chgData name="Mohammed Fasha" userId="cc64f42d-a1a6-4f08-b97b-0c37f877119f" providerId="ADAL" clId="{161A7FAA-B398-4429-9FC2-656B0895AF0F}" dt="2025-07-16T08:07:56.853" v="113" actId="404"/>
-          <ac:spMkLst>
-            <pc:docMk/>
-            <pc:sldMk cId="575657110" sldId="479"/>
-            <ac:spMk id="2" creationId="{4ADEBDBE-8C09-D3AD-763D-3410BE9FAF8D}"/>
-          </ac:spMkLst>
-        </pc:spChg>
-        <pc:spChg chg="add mod">
-          <ac:chgData name="Mohammed Fasha" userId="cc64f42d-a1a6-4f08-b97b-0c37f877119f" providerId="ADAL" clId="{161A7FAA-B398-4429-9FC2-656B0895AF0F}" dt="2025-07-16T08:07:02.451" v="107"/>
-          <ac:spMkLst>
-            <pc:docMk/>
-            <pc:sldMk cId="575657110" sldId="479"/>
-            <ac:spMk id="4" creationId="{61048862-B9F5-1154-77E8-4D0F5E449B7F}"/>
-          </ac:spMkLst>
-        </pc:spChg>
       </pc:sldChg>
       <pc:sldChg chg="modSp new mod">
         <pc:chgData name="Mohammed Fasha" userId="cc64f42d-a1a6-4f08-b97b-0c37f877119f" providerId="ADAL" clId="{161A7FAA-B398-4429-9FC2-656B0895AF0F}" dt="2025-07-16T08:12:50.396" v="164" actId="5793"/>
@@ -1185,14 +1128,6 @@
             <pc:docMk/>
             <pc:sldMk cId="3075052158" sldId="480"/>
             <ac:spMk id="3" creationId="{E520913F-E7B6-47CD-911A-B7E553D5285A}"/>
-          </ac:spMkLst>
-        </pc:spChg>
-        <pc:spChg chg="add mod">
-          <ac:chgData name="Mohammed Fasha" userId="cc64f42d-a1a6-4f08-b97b-0c37f877119f" providerId="ADAL" clId="{161A7FAA-B398-4429-9FC2-656B0895AF0F}" dt="2025-07-16T08:13:08.318" v="167"/>
-          <ac:spMkLst>
-            <pc:docMk/>
-            <pc:sldMk cId="3075052158" sldId="480"/>
-            <ac:spMk id="4" creationId="{5B28E922-3593-82D7-6A03-F52CCB4BFE39}"/>
           </ac:spMkLst>
         </pc:spChg>
         <pc:picChg chg="add mod">
@@ -1400,6 +1335,116 @@
     </pc:docChg>
   </pc:docChgLst>
   <pc:docChgLst>
+    <pc:chgData name="Mohammed Fasha" userId="cc64f42d-a1a6-4f08-b97b-0c37f877119f" providerId="ADAL" clId="{0455E0E6-2388-40FF-8789-A613D1CB1008}"/>
+    <pc:docChg chg="undo custSel modSld">
+      <pc:chgData name="Mohammed Fasha" userId="cc64f42d-a1a6-4f08-b97b-0c37f877119f" providerId="ADAL" clId="{0455E0E6-2388-40FF-8789-A613D1CB1008}" dt="2025-07-26T17:40:12.463" v="95" actId="1076"/>
+      <pc:docMkLst>
+        <pc:docMk/>
+      </pc:docMkLst>
+      <pc:sldChg chg="modSp mod">
+        <pc:chgData name="Mohammed Fasha" userId="cc64f42d-a1a6-4f08-b97b-0c37f877119f" providerId="ADAL" clId="{0455E0E6-2388-40FF-8789-A613D1CB1008}" dt="2025-07-26T15:01:03.233" v="3" actId="27636"/>
+        <pc:sldMkLst>
+          <pc:docMk/>
+          <pc:sldMk cId="1427723282" sldId="462"/>
+        </pc:sldMkLst>
+        <pc:spChg chg="mod">
+          <ac:chgData name="Mohammed Fasha" userId="cc64f42d-a1a6-4f08-b97b-0c37f877119f" providerId="ADAL" clId="{0455E0E6-2388-40FF-8789-A613D1CB1008}" dt="2025-07-26T15:01:03.233" v="3" actId="27636"/>
+          <ac:spMkLst>
+            <pc:docMk/>
+            <pc:sldMk cId="1427723282" sldId="462"/>
+            <ac:spMk id="2" creationId="{5161A592-C95D-5F4C-D812-FDE1F8B67D98}"/>
+          </ac:spMkLst>
+        </pc:spChg>
+      </pc:sldChg>
+      <pc:sldChg chg="addSp delSp modSp mod modClrScheme chgLayout">
+        <pc:chgData name="Mohammed Fasha" userId="cc64f42d-a1a6-4f08-b97b-0c37f877119f" providerId="ADAL" clId="{0455E0E6-2388-40FF-8789-A613D1CB1008}" dt="2025-07-26T15:01:41.656" v="43" actId="313"/>
+        <pc:sldMkLst>
+          <pc:docMk/>
+          <pc:sldMk cId="3941017664" sldId="482"/>
+        </pc:sldMkLst>
+        <pc:spChg chg="del mod ord">
+          <ac:chgData name="Mohammed Fasha" userId="cc64f42d-a1a6-4f08-b97b-0c37f877119f" providerId="ADAL" clId="{0455E0E6-2388-40FF-8789-A613D1CB1008}" dt="2025-07-26T15:01:25.721" v="5" actId="700"/>
+          <ac:spMkLst>
+            <pc:docMk/>
+            <pc:sldMk cId="3941017664" sldId="482"/>
+            <ac:spMk id="2" creationId="{4AB508A7-8888-D77B-B430-86487FE1DB28}"/>
+          </ac:spMkLst>
+        </pc:spChg>
+        <pc:spChg chg="del mod ord">
+          <ac:chgData name="Mohammed Fasha" userId="cc64f42d-a1a6-4f08-b97b-0c37f877119f" providerId="ADAL" clId="{0455E0E6-2388-40FF-8789-A613D1CB1008}" dt="2025-07-26T15:01:25.721" v="5" actId="700"/>
+          <ac:spMkLst>
+            <pc:docMk/>
+            <pc:sldMk cId="3941017664" sldId="482"/>
+            <ac:spMk id="3" creationId="{28A4CF1C-C04B-6B0E-66D9-A9DDA7F6AA70}"/>
+          </ac:spMkLst>
+        </pc:spChg>
+        <pc:spChg chg="add mod ord">
+          <ac:chgData name="Mohammed Fasha" userId="cc64f42d-a1a6-4f08-b97b-0c37f877119f" providerId="ADAL" clId="{0455E0E6-2388-40FF-8789-A613D1CB1008}" dt="2025-07-26T15:01:41.656" v="43" actId="313"/>
+          <ac:spMkLst>
+            <pc:docMk/>
+            <pc:sldMk cId="3941017664" sldId="482"/>
+            <ac:spMk id="4" creationId="{8E2EA1D2-44C5-E332-39BC-CE451FE205E7}"/>
+          </ac:spMkLst>
+        </pc:spChg>
+        <pc:spChg chg="add mod ord">
+          <ac:chgData name="Mohammed Fasha" userId="cc64f42d-a1a6-4f08-b97b-0c37f877119f" providerId="ADAL" clId="{0455E0E6-2388-40FF-8789-A613D1CB1008}" dt="2025-07-26T15:01:25.721" v="5" actId="700"/>
+          <ac:spMkLst>
+            <pc:docMk/>
+            <pc:sldMk cId="3941017664" sldId="482"/>
+            <ac:spMk id="5" creationId="{ABCBDB70-511E-63F0-2A2E-C4DED7350238}"/>
+          </ac:spMkLst>
+        </pc:spChg>
+      </pc:sldChg>
+      <pc:sldChg chg="addSp delSp modSp mod">
+        <pc:chgData name="Mohammed Fasha" userId="cc64f42d-a1a6-4f08-b97b-0c37f877119f" providerId="ADAL" clId="{0455E0E6-2388-40FF-8789-A613D1CB1008}" dt="2025-07-26T17:40:12.463" v="95" actId="1076"/>
+        <pc:sldMkLst>
+          <pc:docMk/>
+          <pc:sldMk cId="1291192180" sldId="483"/>
+        </pc:sldMkLst>
+        <pc:spChg chg="add del mod">
+          <ac:chgData name="Mohammed Fasha" userId="cc64f42d-a1a6-4f08-b97b-0c37f877119f" providerId="ADAL" clId="{0455E0E6-2388-40FF-8789-A613D1CB1008}" dt="2025-07-26T17:40:12.463" v="95" actId="1076"/>
+          <ac:spMkLst>
+            <pc:docMk/>
+            <pc:sldMk cId="1291192180" sldId="483"/>
+            <ac:spMk id="2" creationId="{269DA4D1-C52F-51DE-82E4-4CE2A0A5B4F9}"/>
+          </ac:spMkLst>
+        </pc:spChg>
+        <pc:spChg chg="mod">
+          <ac:chgData name="Mohammed Fasha" userId="cc64f42d-a1a6-4f08-b97b-0c37f877119f" providerId="ADAL" clId="{0455E0E6-2388-40FF-8789-A613D1CB1008}" dt="2025-07-26T15:06:53.019" v="86" actId="20577"/>
+          <ac:spMkLst>
+            <pc:docMk/>
+            <pc:sldMk cId="1291192180" sldId="483"/>
+            <ac:spMk id="3" creationId="{313D3DFB-4B7B-5020-971F-AF2B7A0A35FA}"/>
+          </ac:spMkLst>
+        </pc:spChg>
+        <pc:spChg chg="add">
+          <ac:chgData name="Mohammed Fasha" userId="cc64f42d-a1a6-4f08-b97b-0c37f877119f" providerId="ADAL" clId="{0455E0E6-2388-40FF-8789-A613D1CB1008}" dt="2025-07-26T17:39:42.717" v="87"/>
+          <ac:spMkLst>
+            <pc:docMk/>
+            <pc:sldMk cId="1291192180" sldId="483"/>
+            <ac:spMk id="4" creationId="{78257968-A349-C409-8BA2-16BC23D00E70}"/>
+          </ac:spMkLst>
+        </pc:spChg>
+        <pc:spChg chg="add mod">
+          <ac:chgData name="Mohammed Fasha" userId="cc64f42d-a1a6-4f08-b97b-0c37f877119f" providerId="ADAL" clId="{0455E0E6-2388-40FF-8789-A613D1CB1008}" dt="2025-07-26T17:39:58.898" v="90"/>
+          <ac:spMkLst>
+            <pc:docMk/>
+            <pc:sldMk cId="1291192180" sldId="483"/>
+            <ac:spMk id="5" creationId="{7A138DF1-02E8-85BC-68FA-8234ED2E27FF}"/>
+          </ac:spMkLst>
+        </pc:spChg>
+        <pc:spChg chg="add mod">
+          <ac:chgData name="Mohammed Fasha" userId="cc64f42d-a1a6-4f08-b97b-0c37f877119f" providerId="ADAL" clId="{0455E0E6-2388-40FF-8789-A613D1CB1008}" dt="2025-07-26T17:40:11.524" v="94" actId="1076"/>
+          <ac:spMkLst>
+            <pc:docMk/>
+            <pc:sldMk cId="1291192180" sldId="483"/>
+            <ac:spMk id="6" creationId="{753DAA7F-8E19-6902-2AEC-999C70373321}"/>
+          </ac:spMkLst>
+        </pc:spChg>
+      </pc:sldChg>
+    </pc:docChg>
+  </pc:docChgLst>
+  <pc:docChgLst>
     <pc:chgData name="Mohammed Fasha" userId="cc64f42d-a1a6-4f08-b97b-0c37f877119f" providerId="ADAL" clId="{D1859E10-E91F-4CD4-B9AD-657F2116AC8C}"/>
     <pc:docChg chg="custSel modMainMaster">
       <pc:chgData name="Mohammed Fasha" userId="cc64f42d-a1a6-4f08-b97b-0c37f877119f" providerId="ADAL" clId="{D1859E10-E91F-4CD4-B9AD-657F2116AC8C}" dt="2024-11-09T05:23:14.444" v="3" actId="1076"/>
@@ -1779,7 +1824,7 @@
           <a:p>
             <a:fld id="{D83FB9BE-DA6C-46CF-8E77-0CE63E601AD4}" type="datetimeFigureOut">
               <a:rPr lang="en-US" smtClean="0"/>
-              <a:t>7/16/2025</a:t>
+              <a:t>7/26/2025</a:t>
             </a:fld>
             <a:endParaRPr lang="en-US"/>
           </a:p>
@@ -1977,7 +2022,7 @@
           <a:p>
             <a:fld id="{D83FB9BE-DA6C-46CF-8E77-0CE63E601AD4}" type="datetimeFigureOut">
               <a:rPr lang="en-US" smtClean="0"/>
-              <a:t>7/16/2025</a:t>
+              <a:t>7/26/2025</a:t>
             </a:fld>
             <a:endParaRPr lang="en-US"/>
           </a:p>
@@ -2185,7 +2230,7 @@
           <a:p>
             <a:fld id="{D83FB9BE-DA6C-46CF-8E77-0CE63E601AD4}" type="datetimeFigureOut">
               <a:rPr lang="en-US" smtClean="0"/>
-              <a:t>7/16/2025</a:t>
+              <a:t>7/26/2025</a:t>
             </a:fld>
             <a:endParaRPr lang="en-US"/>
           </a:p>
@@ -2598,7 +2643,7 @@
           <a:p>
             <a:fld id="{D83FB9BE-DA6C-46CF-8E77-0CE63E601AD4}" type="datetimeFigureOut">
               <a:rPr lang="en-US" smtClean="0"/>
-              <a:t>7/16/2025</a:t>
+              <a:t>7/26/2025</a:t>
             </a:fld>
             <a:endParaRPr lang="en-US"/>
           </a:p>
@@ -2863,7 +2908,7 @@
           <a:p>
             <a:fld id="{D83FB9BE-DA6C-46CF-8E77-0CE63E601AD4}" type="datetimeFigureOut">
               <a:rPr lang="en-US" smtClean="0"/>
-              <a:t>7/16/2025</a:t>
+              <a:t>7/26/2025</a:t>
             </a:fld>
             <a:endParaRPr lang="en-US"/>
           </a:p>
@@ -3275,7 +3320,7 @@
           <a:p>
             <a:fld id="{D83FB9BE-DA6C-46CF-8E77-0CE63E601AD4}" type="datetimeFigureOut">
               <a:rPr lang="en-US" smtClean="0"/>
-              <a:t>7/16/2025</a:t>
+              <a:t>7/26/2025</a:t>
             </a:fld>
             <a:endParaRPr lang="en-US"/>
           </a:p>
@@ -3416,7 +3461,7 @@
           <a:p>
             <a:fld id="{D83FB9BE-DA6C-46CF-8E77-0CE63E601AD4}" type="datetimeFigureOut">
               <a:rPr lang="en-US" smtClean="0"/>
-              <a:t>7/16/2025</a:t>
+              <a:t>7/26/2025</a:t>
             </a:fld>
             <a:endParaRPr lang="en-US"/>
           </a:p>
@@ -3529,7 +3574,7 @@
           <a:p>
             <a:fld id="{D83FB9BE-DA6C-46CF-8E77-0CE63E601AD4}" type="datetimeFigureOut">
               <a:rPr lang="en-US" smtClean="0"/>
-              <a:t>7/16/2025</a:t>
+              <a:t>7/26/2025</a:t>
             </a:fld>
             <a:endParaRPr lang="en-US"/>
           </a:p>
@@ -3840,7 +3885,7 @@
           <a:p>
             <a:fld id="{D83FB9BE-DA6C-46CF-8E77-0CE63E601AD4}" type="datetimeFigureOut">
               <a:rPr lang="en-US" smtClean="0"/>
-              <a:t>7/16/2025</a:t>
+              <a:t>7/26/2025</a:t>
             </a:fld>
             <a:endParaRPr lang="en-US"/>
           </a:p>
@@ -4128,7 +4173,7 @@
           <a:p>
             <a:fld id="{D83FB9BE-DA6C-46CF-8E77-0CE63E601AD4}" type="datetimeFigureOut">
               <a:rPr lang="en-US" smtClean="0"/>
-              <a:t>7/16/2025</a:t>
+              <a:t>7/26/2025</a:t>
             </a:fld>
             <a:endParaRPr lang="en-US"/>
           </a:p>
@@ -4369,7 +4414,7 @@
           <a:p>
             <a:fld id="{D83FB9BE-DA6C-46CF-8E77-0CE63E601AD4}" type="datetimeFigureOut">
               <a:rPr lang="en-US" smtClean="0"/>
-              <a:t>7/16/2025</a:t>
+              <a:t>7/26/2025</a:t>
             </a:fld>
             <a:endParaRPr lang="en-US"/>
           </a:p>
@@ -6112,62 +6157,30 @@
         </p:spPr>
         <p:txBody>
           <a:bodyPr>
-            <a:normAutofit fontScale="85000" lnSpcReduction="10000"/>
+            <a:normAutofit/>
           </a:bodyPr>
           <a:lstStyle/>
           <a:p>
             <a:r>
-              <a:rPr lang="en-US" dirty="0"/>
+              <a:rPr lang="en-US" sz="2000" dirty="0"/>
               <a:t>A linear regression model can be trained using </a:t>
             </a:r>
             <a:r>
-              <a:rPr lang="en-US" b="1" i="1" dirty="0"/>
+              <a:rPr lang="en-US" sz="2000" b="1" dirty="0"/>
               <a:t>Gradient Descent</a:t>
             </a:r>
             <a:r>
-              <a:rPr lang="en-US" dirty="0"/>
+              <a:rPr lang="en-US" sz="2000" dirty="0"/>
               <a:t>, which adjusts the model's parameters to minimize the mean squared error (MSE).</a:t>
             </a:r>
           </a:p>
           <a:p>
             <a:r>
-              <a:rPr lang="en-US" dirty="0"/>
-              <a:t>To update (</a:t>
-            </a:r>
-            <a:r>
-              <a:rPr lang="en-US" i="1" dirty="0"/>
-              <a:t>Beta 0) </a:t>
-            </a:r>
-            <a:r>
-              <a:rPr lang="en-US" dirty="0"/>
-              <a:t>and (</a:t>
-            </a:r>
-            <a:r>
-              <a:rPr lang="en-US" i="1" dirty="0"/>
-              <a:t>Beta 1)</a:t>
-            </a:r>
-            <a:r>
-              <a:rPr lang="en-US" dirty="0"/>
-              <a:t> and reduce the cost function (minimizing the RMSE), gradient descent starts with random values for (</a:t>
-            </a:r>
-            <a:r>
-              <a:rPr lang="en-US" i="1" dirty="0"/>
-              <a:t>Beta 0) </a:t>
-            </a:r>
-            <a:r>
-              <a:rPr lang="en-US" dirty="0"/>
-              <a:t>and (</a:t>
-            </a:r>
-            <a:r>
-              <a:rPr lang="en-US" i="1" dirty="0"/>
-              <a:t>Beta 1) </a:t>
-            </a:r>
-            <a:r>
-              <a:rPr lang="en-US" dirty="0"/>
-              <a:t>and </a:t>
-            </a:r>
-            <a:r>
-              <a:rPr lang="en-US" b="1" i="1" dirty="0">
+              <a:rPr lang="en-US" sz="2000" dirty="0"/>
+              <a:t>To update (Beta 0) and (Beta 1) and reduce the cost function (minimizing the RMSE), gradient descent starts with random values for (Beta 0) and (Beta 1) and </a:t>
+            </a:r>
+            <a:r>
+              <a:rPr lang="en-US" sz="2000" b="1" dirty="0">
                 <a:solidFill>
                   <a:srgbClr val="FF0000"/>
                 </a:solidFill>
@@ -6175,19 +6188,19 @@
               <a:t>iteratively</a:t>
             </a:r>
             <a:r>
-              <a:rPr lang="en-US" dirty="0"/>
+              <a:rPr lang="en-US" sz="2000" dirty="0"/>
               <a:t> improves them to find the best-fit line.</a:t>
             </a:r>
           </a:p>
           <a:p>
             <a:r>
-              <a:rPr lang="en-US" dirty="0"/>
+              <a:rPr lang="en-US" sz="2000" dirty="0"/>
               <a:t>A gradient is simply the derivative, showing how small changes in inputs affect the output. </a:t>
             </a:r>
           </a:p>
           <a:p>
             <a:r>
-              <a:rPr lang="en-US" dirty="0"/>
+              <a:rPr lang="en-US" sz="2000" dirty="0"/>
               <a:t>By moving in the direction of the Mean Squared Error negative gradient with respect to the coefficients, the coefficients can be changed.</a:t>
             </a:r>
           </a:p>
@@ -6283,10 +6296,10 @@
       </p:grpSpPr>
       <p:sp>
         <p:nvSpPr>
-          <p:cNvPr id="2" name="Content Placeholder 1">
-            <a:extLst>
-              <a:ext uri="{FF2B5EF4-FFF2-40B4-BE49-F238E27FC236}">
-                <a16:creationId xmlns:a16="http://schemas.microsoft.com/office/drawing/2014/main" id="{4AB508A7-8888-D77B-B430-86487FE1DB28}"/>
+          <p:cNvPr id="4" name="Title 3">
+            <a:extLst>
+              <a:ext uri="{FF2B5EF4-FFF2-40B4-BE49-F238E27FC236}">
+                <a16:creationId xmlns:a16="http://schemas.microsoft.com/office/drawing/2014/main" id="{8E2EA1D2-44C5-E332-39BC-CE451FE205E7}"/>
               </a:ext>
             </a:extLst>
           </p:cNvPr>
@@ -6294,7 +6307,7 @@
             <a:spLocks noGrp="1"/>
           </p:cNvSpPr>
           <p:nvPr>
-            <p:ph idx="1"/>
+            <p:ph type="title"/>
           </p:nvPr>
         </p:nvSpPr>
         <p:spPr/>
@@ -6302,16 +6315,19 @@
           <a:bodyPr/>
           <a:lstStyle/>
           <a:p>
-            <a:endParaRPr lang="en-US"/>
-          </a:p>
-        </p:txBody>
-      </p:sp>
-      <p:sp>
-        <p:nvSpPr>
-          <p:cNvPr id="3" name="Title 2">
-            <a:extLst>
-              <a:ext uri="{FF2B5EF4-FFF2-40B4-BE49-F238E27FC236}">
-                <a16:creationId xmlns:a16="http://schemas.microsoft.com/office/drawing/2014/main" id="{28A4CF1C-C04B-6B0E-66D9-A9DDA7F6AA70}"/>
+            <a:r>
+              <a:rPr lang="en-US" dirty="0"/>
+              <a:t>Implement Regression in Python</a:t>
+            </a:r>
+          </a:p>
+        </p:txBody>
+      </p:sp>
+      <p:sp>
+        <p:nvSpPr>
+          <p:cNvPr id="5" name="Text Placeholder 4">
+            <a:extLst>
+              <a:ext uri="{FF2B5EF4-FFF2-40B4-BE49-F238E27FC236}">
+                <a16:creationId xmlns:a16="http://schemas.microsoft.com/office/drawing/2014/main" id="{ABCBDB70-511E-63F0-2A2E-C4DED7350238}"/>
               </a:ext>
             </a:extLst>
           </p:cNvPr>
@@ -6319,7 +6335,7 @@
             <a:spLocks noGrp="1"/>
           </p:cNvSpPr>
           <p:nvPr>
-            <p:ph type="title"/>
+            <p:ph type="body" idx="1"/>
           </p:nvPr>
         </p:nvSpPr>
         <p:spPr/>
@@ -6379,35 +6395,44 @@
         </p:nvSpPr>
         <p:spPr/>
         <p:txBody>
+          <a:bodyPr>
+            <a:normAutofit/>
+          </a:bodyPr>
+          <a:lstStyle/>
+          <a:p>
+            <a:endParaRPr lang="en-US" sz="1600" noProof="1"/>
+          </a:p>
+        </p:txBody>
+      </p:sp>
+      <p:sp>
+        <p:nvSpPr>
+          <p:cNvPr id="3" name="Title 2">
+            <a:extLst>
+              <a:ext uri="{FF2B5EF4-FFF2-40B4-BE49-F238E27FC236}">
+                <a16:creationId xmlns:a16="http://schemas.microsoft.com/office/drawing/2014/main" id="{313D3DFB-4B7B-5020-971F-AF2B7A0A35FA}"/>
+              </a:ext>
+            </a:extLst>
+          </p:cNvPr>
+          <p:cNvSpPr>
+            <a:spLocks noGrp="1"/>
+          </p:cNvSpPr>
+          <p:nvPr>
+            <p:ph type="title"/>
+          </p:nvPr>
+        </p:nvSpPr>
+        <p:spPr/>
+        <p:txBody>
           <a:bodyPr/>
           <a:lstStyle/>
           <a:p>
-            <a:endParaRPr lang="en-US"/>
-          </a:p>
-        </p:txBody>
-      </p:sp>
-      <p:sp>
-        <p:nvSpPr>
-          <p:cNvPr id="3" name="Title 2">
-            <a:extLst>
-              <a:ext uri="{FF2B5EF4-FFF2-40B4-BE49-F238E27FC236}">
-                <a16:creationId xmlns:a16="http://schemas.microsoft.com/office/drawing/2014/main" id="{313D3DFB-4B7B-5020-971F-AF2B7A0A35FA}"/>
-              </a:ext>
-            </a:extLst>
-          </p:cNvPr>
-          <p:cNvSpPr>
-            <a:spLocks noGrp="1"/>
-          </p:cNvSpPr>
-          <p:nvPr>
-            <p:ph type="title"/>
-          </p:nvPr>
-        </p:nvSpPr>
-        <p:spPr/>
-        <p:txBody>
-          <a:bodyPr/>
-          <a:lstStyle/>
-          <a:p>
-            <a:endParaRPr lang="en-US"/>
+            <a:r>
+              <a:rPr lang="en-US" dirty="0"/>
+              <a:t>Import the </a:t>
+            </a:r>
+            <a:r>
+              <a:rPr lang="en-US"/>
+              <a:t>Required Libraries</a:t>
+            </a:r>
           </a:p>
         </p:txBody>
       </p:sp>

</xml_diff>